<commit_message>
Re-run the real-data validation on the current code and refresh the docs
- CGMacros (45 adults) re-evaluated after the CGM gap-fill fix: forecast
  errors unchanged to within 0.1 mg/dL; alerts now 207/298 excursions
  flagged, median lead 41 min, 1.18 false alerts per participant-day
  (was 211/298, 46 min, 1.20)
- README, REAL_DATA_VALIDATION.md, the figure, the PowerPoint, and both
  PDFs updated from the new results; the "re-run pending" note is removed
</commit_message>
<xml_diff>
--- a/docs/GlucoTwin_Presentation.pptx
+++ b/docs/GlucoTwin_Presentation.pptx
@@ -1437,19 +1437,13 @@
           <a:p/>
           <a:p>
             <a:r>
-              <a:t>The full hybrid reaches 22.5 at sixty minutes against 29.1 for persistence, 22 percent lower, and beats the CGM-only model at every horizon. Alerts flagged 211 of 298 excursions, median lead 46 minutes, at 1.20 false alerts a day: close to our target of one, not yet under it.</a:t>
+              <a:t>The full hybrid reaches 22.5 at sixty minutes against 29.1 for persistence, 23 percent lower, and beats the CGM-only model at every horizon. Alerts flagged 207 of 298 excursions, median lead 41 minutes, at 1.18 false alerts a day: close to our target of one, not yet under it.</a:t>
             </a:r>
           </a:p>
           <a:p/>
           <a:p>
             <a:r>
               <a:t>Where it does not help: the twin alone is worse than persistence at thirty minutes, and fasting labs add nothing measurable with forty-five people. The cohort is American, with no HRV or sleep data.</a:t>
-            </a:r>
-          </a:p>
-          <a:p/>
-          <a:p>
-            <a:r>
-              <a:t>[Presenter note, not spoken: these real-data figures were computed before a later gap-fill fix that moved the synthetic results by 1 to 3 percent; a re-run is pending.]</a:t>
             </a:r>
           </a:p>
         </p:txBody>
@@ -8704,7 +8698,7 @@
                           </a:solidFill>
                           <a:latin typeface="Calibri"/>
                         </a:rPr>
-                        <a:t>28.7</a:t>
+                        <a:t>28.6</a:t>
                       </a:r>
                     </a:p>
                   </a:txBody>
@@ -8940,7 +8934,7 @@
                           </a:solidFill>
                           <a:latin typeface="Calibri"/>
                         </a:rPr>
-                        <a:t>15.6</a:t>
+                        <a:t>15.5</a:t>
                       </a:r>
                     </a:p>
                   </a:txBody>
@@ -8986,7 +8980,7 @@
                           </a:solidFill>
                           <a:latin typeface="Calibri"/>
                         </a:rPr>
-                        <a:t>27.1</a:t>
+                        <a:t>27.2</a:t>
                       </a:r>
                     </a:p>
                   </a:txBody>
@@ -9077,7 +9071,7 @@
                 </a:solidFill>
                 <a:latin typeface="Cambria"/>
               </a:rPr>
-              <a:t>22%</a:t>
+              <a:t>23%</a:t>
             </a:r>
           </a:p>
         </p:txBody>
@@ -9193,7 +9187,7 @@
                 </a:solidFill>
                 <a:latin typeface="Cambria"/>
               </a:rPr>
-              <a:t>211/298</a:t>
+              <a:t>207/298</a:t>
             </a:r>
           </a:p>
         </p:txBody>
@@ -9228,7 +9222,7 @@
                 </a:solidFill>
                 <a:latin typeface="Calibri"/>
               </a:rPr>
-              <a:t>excursions flagged in advance, median lead 46 min</a:t>
+              <a:t>excursions flagged in advance, median lead 41 min</a:t>
             </a:r>
           </a:p>
         </p:txBody>
@@ -9309,7 +9303,7 @@
                 </a:solidFill>
                 <a:latin typeface="Cambria"/>
               </a:rPr>
-              <a:t>1.20</a:t>
+              <a:t>1.18</a:t>
             </a:r>
           </a:p>
         </p:txBody>
@@ -9483,7 +9477,7 @@
                 </a:solidFill>
                 <a:latin typeface="Calibri"/>
               </a:rPr>
-              <a:t>Data: Gutierrez-Osuna et al., CGMacros v1.0.0, PhysioNet 2025, CC BY-NC-SA 4.0.  Computed before a later gap-fill fix; re-run pending.</a:t>
+              <a:t>Data: Gutierrez-Osuna et al., CGMacros v1.0.0, PhysioNet 2025, CC BY-NC-SA 4.0.</a:t>
             </a:r>
           </a:p>
         </p:txBody>

</xml_diff>